<commit_message>
reduce size of cover
</commit_message>
<xml_diff>
--- a/assets/images_papers/papers_ckntav_template.pptx
+++ b/assets/images_papers/papers_ckntav_template.pptx
@@ -9,7 +9,7 @@
   </p:notesMasterIdLst>
   <p:sldIdLst>
     <p:sldId id="264" r:id="rId2"/>
-    <p:sldId id="265" r:id="rId3"/>
+    <p:sldId id="266" r:id="rId3"/>
   </p:sldIdLst>
   <p:sldSz cx="7775575" cy="10044113"/>
   <p:notesSz cx="6858000" cy="9144000"/>
@@ -198,7 +198,7 @@
           <a:p>
             <a:fld id="{B412DFD0-D537-B343-9972-2F88FB06FE28}" type="datetimeFigureOut">
               <a:rPr lang="fr-FR" smtClean="0"/>
-              <a:t>13/06/2024</a:t>
+              <a:t>14/06/2024</a:t>
             </a:fld>
             <a:endParaRPr lang="fr-FR"/>
           </a:p>
@@ -597,7 +597,7 @@
           <a:p>
             <a:fld id="{FD61F8CB-2676-0E4E-997A-93DE7A441BDD}" type="datetimeFigureOut">
               <a:rPr lang="fr-FR" smtClean="0"/>
-              <a:t>13/06/2024</a:t>
+              <a:t>14/06/2024</a:t>
             </a:fld>
             <a:endParaRPr lang="fr-FR"/>
           </a:p>
@@ -767,7 +767,7 @@
           <a:p>
             <a:fld id="{FD61F8CB-2676-0E4E-997A-93DE7A441BDD}" type="datetimeFigureOut">
               <a:rPr lang="fr-FR" smtClean="0"/>
-              <a:t>13/06/2024</a:t>
+              <a:t>14/06/2024</a:t>
             </a:fld>
             <a:endParaRPr lang="fr-FR"/>
           </a:p>
@@ -947,7 +947,7 @@
           <a:p>
             <a:fld id="{FD61F8CB-2676-0E4E-997A-93DE7A441BDD}" type="datetimeFigureOut">
               <a:rPr lang="fr-FR" smtClean="0"/>
-              <a:t>13/06/2024</a:t>
+              <a:t>14/06/2024</a:t>
             </a:fld>
             <a:endParaRPr lang="fr-FR"/>
           </a:p>
@@ -1117,7 +1117,7 @@
           <a:p>
             <a:fld id="{FD61F8CB-2676-0E4E-997A-93DE7A441BDD}" type="datetimeFigureOut">
               <a:rPr lang="fr-FR" smtClean="0"/>
-              <a:t>13/06/2024</a:t>
+              <a:t>14/06/2024</a:t>
             </a:fld>
             <a:endParaRPr lang="fr-FR"/>
           </a:p>
@@ -1363,7 +1363,7 @@
           <a:p>
             <a:fld id="{FD61F8CB-2676-0E4E-997A-93DE7A441BDD}" type="datetimeFigureOut">
               <a:rPr lang="fr-FR" smtClean="0"/>
-              <a:t>13/06/2024</a:t>
+              <a:t>14/06/2024</a:t>
             </a:fld>
             <a:endParaRPr lang="fr-FR"/>
           </a:p>
@@ -1595,7 +1595,7 @@
           <a:p>
             <a:fld id="{FD61F8CB-2676-0E4E-997A-93DE7A441BDD}" type="datetimeFigureOut">
               <a:rPr lang="fr-FR" smtClean="0"/>
-              <a:t>13/06/2024</a:t>
+              <a:t>14/06/2024</a:t>
             </a:fld>
             <a:endParaRPr lang="fr-FR"/>
           </a:p>
@@ -1962,7 +1962,7 @@
           <a:p>
             <a:fld id="{FD61F8CB-2676-0E4E-997A-93DE7A441BDD}" type="datetimeFigureOut">
               <a:rPr lang="fr-FR" smtClean="0"/>
-              <a:t>13/06/2024</a:t>
+              <a:t>14/06/2024</a:t>
             </a:fld>
             <a:endParaRPr lang="fr-FR"/>
           </a:p>
@@ -2080,7 +2080,7 @@
           <a:p>
             <a:fld id="{FD61F8CB-2676-0E4E-997A-93DE7A441BDD}" type="datetimeFigureOut">
               <a:rPr lang="fr-FR" smtClean="0"/>
-              <a:t>13/06/2024</a:t>
+              <a:t>14/06/2024</a:t>
             </a:fld>
             <a:endParaRPr lang="fr-FR"/>
           </a:p>
@@ -2175,7 +2175,7 @@
           <a:p>
             <a:fld id="{FD61F8CB-2676-0E4E-997A-93DE7A441BDD}" type="datetimeFigureOut">
               <a:rPr lang="fr-FR" smtClean="0"/>
-              <a:t>13/06/2024</a:t>
+              <a:t>14/06/2024</a:t>
             </a:fld>
             <a:endParaRPr lang="fr-FR"/>
           </a:p>
@@ -2452,7 +2452,7 @@
           <a:p>
             <a:fld id="{FD61F8CB-2676-0E4E-997A-93DE7A441BDD}" type="datetimeFigureOut">
               <a:rPr lang="fr-FR" smtClean="0"/>
-              <a:t>13/06/2024</a:t>
+              <a:t>14/06/2024</a:t>
             </a:fld>
             <a:endParaRPr lang="fr-FR"/>
           </a:p>
@@ -2709,7 +2709,7 @@
           <a:p>
             <a:fld id="{FD61F8CB-2676-0E4E-997A-93DE7A441BDD}" type="datetimeFigureOut">
               <a:rPr lang="fr-FR" smtClean="0"/>
-              <a:t>13/06/2024</a:t>
+              <a:t>14/06/2024</a:t>
             </a:fld>
             <a:endParaRPr lang="fr-FR"/>
           </a:p>
@@ -2922,7 +2922,7 @@
           <a:p>
             <a:fld id="{FD61F8CB-2676-0E4E-997A-93DE7A441BDD}" type="datetimeFigureOut">
               <a:rPr lang="fr-FR" smtClean="0"/>
-              <a:t>13/06/2024</a:t>
+              <a:t>14/06/2024</a:t>
             </a:fld>
             <a:endParaRPr lang="fr-FR"/>
           </a:p>
@@ -3523,7 +3523,7 @@
     </p:spTree>
     <p:extLst>
       <p:ext uri="{BB962C8B-B14F-4D97-AF65-F5344CB8AC3E}">
-        <p14:creationId xmlns:p14="http://schemas.microsoft.com/office/powerpoint/2010/main" val="4210480540"/>
+        <p14:creationId xmlns:p14="http://schemas.microsoft.com/office/powerpoint/2010/main" val="3706284312"/>
       </p:ext>
     </p:extLst>
   </p:cSld>

</xml_diff>